<commit_message>
docs: document Trivy findings and how the backend CVEs were fixed
</commit_message>
<xml_diff>
--- a/demo/SpendWise-Presentation.pptx
+++ b/demo/SpendWise-Presentation.pptx
@@ -116,32 +116,32 @@
   <p:extLst>
     <p:ext uri="{521415D9-36F7-43E2-AB2F-B90AF26B5E84}">
       <p14:sectionLst xmlns:p14="http://schemas.microsoft.com/office/powerpoint/2010/main">
-        <p14:section name="Intro" id="{1b52a0fc-c212-8f84-9149-2b7ba09c4f01}">
+        <p14:section name="Intro" id="{818ca74b-0821-0738-a5b1-54e984dc1016}">
           <p14:sldIdLst>
             <p14:sldId id="256"/>
             <p14:sldId id="257"/>
           </p14:sldIdLst>
         </p14:section>
-        <p14:section name="Build" id="{23bd8d79-ab65-bdec-864b-8b4141a03163}">
+        <p14:section name="Build" id="{166b75f3-d8a7-d4b1-ada3-a4316f3e6e62}">
           <p14:sldIdLst>
             <p14:sldId id="258"/>
             <p14:sldId id="259"/>
           </p14:sldIdLst>
         </p14:section>
-        <p14:section name="Ship" id="{0897631e-f7f0-91ee-59a6-d557b27923c0}">
+        <p14:section name="Ship" id="{d3f59f41-2ee8-994c-755c-233b11da112c}">
           <p14:sldIdLst>
             <p14:sldId id="260"/>
             <p14:sldId id="261"/>
           </p14:sldIdLst>
         </p14:section>
-        <p14:section name="Run" id="{f020556e-6ff1-365e-47c6-545625e5e632}">
+        <p14:section name="Run" id="{13ddf510-3220-8398-a586-dffc705e89e6}">
           <p14:sldIdLst>
             <p14:sldId id="262"/>
             <p14:sldId id="263"/>
             <p14:sldId id="264"/>
           </p14:sldIdLst>
         </p14:section>
-        <p14:section name="Wrap-up" id="{71316eb5-fb86-a804-5864-d9c574009edc}">
+        <p14:section name="Wrap-up" id="{899eb63e-1ba1-defc-7614-8c536b7cb64f}">
           <p14:sldIdLst>
             <p14:sldId id="265"/>
           </p14:sldIdLst>
@@ -6383,8 +6383,8 @@
         </p:nvSpPr>
         <p:spPr>
           <a:xfrm>
-            <a:off x="731520" y="3429000"/>
-            <a:ext cx="3383280" cy="731520"/>
+            <a:off x="731520" y="3154680"/>
+            <a:ext cx="3383280" cy="1097280"/>
           </a:xfrm>
           <a:prstGeom prst="rect">
             <a:avLst/>
@@ -6400,14 +6400,14 @@
               <a:buNone/>
             </a:pPr>
             <a:r>
-              <a:rPr lang="en-US" sz="1400" b="1" dirty="0">
+              <a:rPr lang="en-US" sz="1300" b="1" dirty="0">
                 <a:solidFill>
                   <a:schemeClr val="accent3"/>
                 </a:solidFill>
               </a:rPr>
-              <a:t>Result: &lt;fill in from your pipeline run&gt;</a:t>
-            </a:r>
-            <a:endParaRPr lang="en-US" sz="1400" dirty="0"/>
+              <a:t>First run: 7 HIGH CVEs in the backend (e.g. CVE-2025-62727, a Starlette DoS). Fixed by upgrading and using a multi-stage build. Now 0 HIGH/CRITICAL.</a:t>
+            </a:r>
+            <a:endParaRPr lang="en-US" sz="1300" dirty="0"/>
           </a:p>
         </p:txBody>
       </p:sp>

</xml_diff>

<commit_message>
docs(demo): add PDF slide deck and update slides and video script for local cluster
</commit_message>
<xml_diff>
--- a/demo/SpendWise-Presentation.pptx
+++ b/demo/SpendWise-Presentation.pptx
@@ -116,32 +116,32 @@
   <p:extLst>
     <p:ext uri="{521415D9-36F7-43E2-AB2F-B90AF26B5E84}">
       <p14:sectionLst xmlns:p14="http://schemas.microsoft.com/office/powerpoint/2010/main">
-        <p14:section name="Intro" id="{818ca74b-0821-0738-a5b1-54e984dc1016}">
+        <p14:section name="Intro" id="{93ddd7ca-7a3c-1c0b-0589-1294410b56eb}">
           <p14:sldIdLst>
             <p14:sldId id="256"/>
             <p14:sldId id="257"/>
           </p14:sldIdLst>
         </p14:section>
-        <p14:section name="Build" id="{166b75f3-d8a7-d4b1-ada3-a4316f3e6e62}">
+        <p14:section name="Build" id="{73411b5e-76a9-e2f6-ff86-f5b93906ec57}">
           <p14:sldIdLst>
             <p14:sldId id="258"/>
             <p14:sldId id="259"/>
           </p14:sldIdLst>
         </p14:section>
-        <p14:section name="Ship" id="{d3f59f41-2ee8-994c-755c-233b11da112c}">
+        <p14:section name="Ship" id="{7d758fa2-0b7b-c7eb-0334-dd9cef9a069e}">
           <p14:sldIdLst>
             <p14:sldId id="260"/>
             <p14:sldId id="261"/>
           </p14:sldIdLst>
         </p14:section>
-        <p14:section name="Run" id="{13ddf510-3220-8398-a586-dffc705e89e6}">
+        <p14:section name="Run" id="{b2de3124-4158-04e8-af27-f7129ee5a58a}">
           <p14:sldIdLst>
             <p14:sldId id="262"/>
             <p14:sldId id="263"/>
             <p14:sldId id="264"/>
           </p14:sldIdLst>
         </p14:section>
-        <p14:section name="Wrap-up" id="{899eb63e-1ba1-defc-7614-8c536b7cb64f}">
+        <p14:section name="Wrap-up" id="{d1e6cfed-e6e5-9388-8ea9-2f0fae05821b}">
           <p14:sldIdLst>
             <p14:sldId id="265"/>
           </p14:sldIdLst>
@@ -2096,7 +2096,7 @@
                   <a:schemeClr val="accent2"/>
                 </a:solidFill>
               </a:rPr>
-              <a:t>A personal expense tracker, shipped through a full DevSecOps pipeline: GitHub Actions · Trivy · Terraform · EKS · Helm · ArgoCD · Prometheus · Grafana</a:t>
+              <a:t>A personal expense tracker, shipped through a full DevSecOps pipeline: GitHub Actions · Trivy · Terraform · Kubernetes · Helm · ArgoCD · Prometheus · Grafana</a:t>
             </a:r>
             <a:endParaRPr lang="en-US" sz="1800" dirty="0"/>
           </a:p>
@@ -2256,7 +2256,7 @@
                   <a:schemeClr val="tx1"/>
                 </a:solidFill>
               </a:rPr>
-              <a:t>EKS needs add-ons (EBS CSI, Ingress) before stateful apps can run</a:t>
+              <a:t>Terraform can manage local platforms too: one apply builds the whole cluster stack</a:t>
             </a:r>
             <a:endParaRPr lang="en-US" sz="1500" dirty="0"/>
           </a:p>
@@ -2274,7 +2274,7 @@
                   <a:schemeClr val="tx1"/>
                 </a:solidFill>
               </a:rPr>
-              <a:t>Always run terraform destroy: NAT gateways and EKS bill by the hour</a:t>
+              <a:t>Keep a local fallback: cloud accounts can be blocked by activation or billing</a:t>
             </a:r>
             <a:endParaRPr lang="en-US" sz="1500" dirty="0"/>
           </a:p>
@@ -2382,7 +2382,7 @@
                   <a:schemeClr val="accent4"/>
                 </a:solidFill>
               </a:rPr>
-              <a:t>User auth (OAuth2 + JWT)</a:t>
+              <a:t>Apply the AWS Terraform (VPC + EKS)</a:t>
             </a:r>
             <a:endParaRPr lang="en-US" sz="1400" dirty="0"/>
           </a:p>
@@ -2400,7 +2400,7 @@
                   <a:schemeClr val="accent4"/>
                 </a:solidFill>
               </a:rPr>
-              <a:t>TLS with cert-manager</a:t>
+              <a:t>User auth (OAuth2 + JWT)</a:t>
             </a:r>
             <a:endParaRPr lang="en-US" sz="1400" dirty="0"/>
           </a:p>
@@ -2418,7 +2418,7 @@
                   <a:schemeClr val="accent4"/>
                 </a:solidFill>
               </a:rPr>
-              <a:t>Amazon RDS for the database</a:t>
+              <a:t>TLS with cert-manager</a:t>
             </a:r>
             <a:endParaRPr lang="en-US" sz="1400" dirty="0"/>
           </a:p>
@@ -2436,7 +2436,7 @@
                   <a:schemeClr val="accent4"/>
                 </a:solidFill>
               </a:rPr>
-              <a:t>External Secrets</a:t>
+              <a:t>Managed database (Amazon RDS)</a:t>
             </a:r>
             <a:endParaRPr lang="en-US" sz="1400" dirty="0"/>
           </a:p>
@@ -2454,7 +2454,7 @@
                   <a:schemeClr val="accent4"/>
                 </a:solidFill>
               </a:rPr>
-              <a:t>S3 remote state</a:t>
+              <a:t>External Secrets</a:t>
             </a:r>
             <a:endParaRPr lang="en-US" sz="1400" dirty="0"/>
           </a:p>
@@ -2680,7 +2680,7 @@
                   <a:schemeClr val="tx1"/>
                 </a:solidFill>
               </a:rPr>
-              <a:t>take that app from git push to a monitored, autoscaled Kubernetes deployment on AWS with no manual steps.</a:t>
+              <a:t>take that app from git push to a monitored, autoscaled Kubernetes deployment with no manual steps.</a:t>
             </a:r>
             <a:endParaRPr lang="en-US" sz="1500" dirty="0"/>
           </a:p>
@@ -3992,7 +3992,7 @@
                   <a:schemeClr val="accent4"/>
                 </a:solidFill>
               </a:rPr>
-              <a:t>Terraform · AWS VPC · EKS · EBS CSI · IAM (IRSA)</a:t>
+              <a:t>Terraform · kind (Kubernetes 1.35) · AWS VPC + EKS code</a:t>
             </a:r>
             <a:endParaRPr lang="en-US" sz="1200" dirty="0"/>
           </a:p>
@@ -4302,7 +4302,7 @@
         <p:spPr>
           <a:xfrm>
             <a:off x="2194560" y="1161288"/>
-            <a:ext cx="3657600" cy="274320"/>
+            <a:ext cx="4572000" cy="274320"/>
           </a:xfrm>
           <a:prstGeom prst="rect">
             <a:avLst/>
@@ -4323,7 +4323,7 @@
                   <a:schemeClr val="accent4"/>
                 </a:solidFill>
               </a:rPr>
-              <a:t>AWS VPC · EKS cluster</a:t>
+              <a:t>Kubernetes cluster (kind, provisioned by Terraform)</a:t>
             </a:r>
             <a:endParaRPr lang="en-US" sz="1100" dirty="0"/>
           </a:p>
@@ -4400,7 +4400,7 @@
                   <a:schemeClr val="tx1"/>
                 </a:solidFill>
               </a:rPr>
-              <a:t>browser</a:t>
+              <a:t>localhost</a:t>
             </a:r>
             <a:endParaRPr lang="en-US" sz="1200" dirty="0"/>
           </a:p>
@@ -4408,7 +4408,7 @@
       </p:sp>
       <p:sp>
         <p:nvSpPr>
-          <p:cNvPr id="7" name="box-ELB + Ingress"/>
+          <p:cNvPr id="7" name="box-Ingress"/>
           <p:cNvSpPr/>
           <p:nvPr/>
         </p:nvSpPr>
@@ -4463,7 +4463,7 @@
                   <a:schemeClr val="tx1"/>
                 </a:solidFill>
               </a:rPr>
-              <a:t>ELB + Ingress</a:t>
+              <a:t>Ingress</a:t>
             </a:r>
             <a:endParaRPr lang="en-US" sz="1200" dirty="0"/>
           </a:p>
@@ -4708,7 +4708,7 @@
                   <a:schemeClr val="tx1"/>
                 </a:solidFill>
               </a:rPr>
-              <a:t>StatefulSet + EBS</a:t>
+              <a:t>StatefulSet + PVC</a:t>
             </a:r>
             <a:endParaRPr lang="en-US" sz="1200" dirty="0"/>
           </a:p>
@@ -6789,7 +6789,7 @@
                   <a:schemeClr val="accent4"/>
                 </a:solidFill>
               </a:rPr>
-              <a:t>per-job workflow permissions; IRSA role for the EBS driver</a:t>
+              <a:t>per-job workflow permissions; secrets in Kubernetes Secrets</a:t>
             </a:r>
             <a:endParaRPr lang="en-US" sz="1200" dirty="0"/>
           </a:p>
@@ -7028,7 +7028,7 @@
                 <a:ea typeface="Cambria" pitchFamily="34" charset="-122"/>
                 <a:cs typeface="Cambria" pitchFamily="34" charset="-120"/>
               </a:rPr>
-              <a:t>Infrastructure as code: Terraform on AWS</a:t>
+              <a:t>Infrastructure as code: Terraform</a:t>
             </a:r>
             <a:endParaRPr lang="en-US" sz="3000" dirty="0"/>
           </a:p>
@@ -7036,41 +7036,259 @@
       </p:sp>
       <p:sp>
         <p:nvSpPr>
-          <p:cNvPr id="3" name="vpc"/>
+          <p:cNvPr id="3" name="tf-local"/>
           <p:cNvSpPr/>
           <p:nvPr/>
         </p:nvSpPr>
         <p:spPr>
           <a:xfrm>
             <a:off x="457200" y="1143000"/>
-            <a:ext cx="4937760" cy="3291840"/>
+            <a:ext cx="3977640" cy="3291840"/>
           </a:xfrm>
           <a:prstGeom prst="roundRect">
             <a:avLst>
-              <a:gd name="adj" fmla="val 2222"/>
+              <a:gd name="adj" fmla="val 2778"/>
+            </a:avLst>
+          </a:prstGeom>
+          <a:solidFill>
+            <a:schemeClr val="tx2"/>
+          </a:solidFill>
+          <a:ln/>
+          <a:effectLst>
+            <a:outerShdw sx="100000" sy="100000" kx="0" ky="0" algn="bl" rotWithShape="0" blurRad="76200" dist="25400" dir="5400000">
+              <a:srgbClr val="000000">
+                <a:alpha val="12000"/>
+              </a:srgbClr>
+            </a:outerShdw>
+          </a:effectLst>
+        </p:spPr>
+      </p:sp>
+      <p:sp>
+        <p:nvSpPr>
+          <p:cNvPr id="4" name="Text 2"/>
+          <p:cNvSpPr txBox="1"/>
+          <p:nvPr/>
+        </p:nvSpPr>
+        <p:spPr>
+          <a:xfrm>
+            <a:off x="685800" y="1280160"/>
+            <a:ext cx="3566160" cy="365760"/>
+          </a:xfrm>
+          <a:prstGeom prst="rect">
+            <a:avLst/>
+          </a:prstGeom>
+          <a:noFill/>
+          <a:ln/>
+        </p:spPr>
+        <p:txBody>
+          <a:bodyPr wrap="square" lIns="0" tIns="0" rIns="0" bIns="0" rtlCol="0" anchor="t"/>
+          <a:lstStyle/>
+          <a:p>
+            <a:pPr indent="0" marL="0">
+              <a:buNone/>
+            </a:pPr>
+            <a:r>
+              <a:rPr lang="en-US" sz="1800" b="1" dirty="0">
+                <a:solidFill>
+                  <a:schemeClr val="bg1"/>
+                </a:solidFill>
+                <a:latin typeface="Cambria" pitchFamily="34" charset="0"/>
+                <a:ea typeface="Cambria" pitchFamily="34" charset="-122"/>
+                <a:cs typeface="Cambria" pitchFamily="34" charset="-120"/>
+              </a:rPr>
+              <a:t>terraform/local: applied</a:t>
+            </a:r>
+            <a:endParaRPr lang="en-US" sz="1800" dirty="0"/>
+          </a:p>
+        </p:txBody>
+      </p:sp>
+      <p:sp>
+        <p:nvSpPr>
+          <p:cNvPr id="5" name="Text 3"/>
+          <p:cNvSpPr txBox="1"/>
+          <p:nvPr/>
+        </p:nvSpPr>
+        <p:spPr>
+          <a:xfrm>
+            <a:off x="685800" y="1737360"/>
+            <a:ext cx="3566160" cy="1645920"/>
+          </a:xfrm>
+          <a:prstGeom prst="rect">
+            <a:avLst/>
+          </a:prstGeom>
+          <a:noFill/>
+          <a:ln/>
+        </p:spPr>
+        <p:txBody>
+          <a:bodyPr wrap="square" lIns="0" tIns="0" rIns="0" bIns="0" rtlCol="0" anchor="t"/>
+          <a:lstStyle/>
+          <a:p>
+            <a:pPr marL="342900" indent="-342900">
+              <a:spcAft>
+                <a:spcPts val="400"/>
+              </a:spcAft>
+              <a:buSzPct val="100000"/>
+              <a:buChar char="•"/>
+            </a:pPr>
+            <a:r>
+              <a:rPr lang="en-US" sz="1400" dirty="0">
+                <a:solidFill>
+                  <a:schemeClr val="bg2"/>
+                </a:solidFill>
+              </a:rPr>
+              <a:t>kind cluster (Kubernetes 1.35)</a:t>
+            </a:r>
+            <a:endParaRPr lang="en-US" sz="1400" dirty="0"/>
+          </a:p>
+          <a:p>
+            <a:pPr marL="342900" indent="-342900">
+              <a:spcAft>
+                <a:spcPts val="400"/>
+              </a:spcAft>
+              <a:buSzPct val="100000"/>
+              <a:buChar char="•"/>
+            </a:pPr>
+            <a:r>
+              <a:rPr lang="en-US" sz="1400" dirty="0">
+                <a:solidFill>
+                  <a:schemeClr val="bg2"/>
+                </a:solidFill>
+              </a:rPr>
+              <a:t>ingress-nginx</a:t>
+            </a:r>
+            <a:endParaRPr lang="en-US" sz="1400" dirty="0"/>
+          </a:p>
+          <a:p>
+            <a:pPr marL="342900" indent="-342900">
+              <a:spcAft>
+                <a:spcPts val="400"/>
+              </a:spcAft>
+              <a:buSzPct val="100000"/>
+              <a:buChar char="•"/>
+            </a:pPr>
+            <a:r>
+              <a:rPr lang="en-US" sz="1400" dirty="0">
+                <a:solidFill>
+                  <a:schemeClr val="bg2"/>
+                </a:solidFill>
+              </a:rPr>
+              <a:t>metrics-server (feeds the HPA)</a:t>
+            </a:r>
+            <a:endParaRPr lang="en-US" sz="1400" dirty="0"/>
+          </a:p>
+          <a:p>
+            <a:pPr marL="342900" indent="-342900">
+              <a:spcAft>
+                <a:spcPts val="400"/>
+              </a:spcAft>
+              <a:buSzPct val="100000"/>
+              <a:buChar char="•"/>
+            </a:pPr>
+            <a:r>
+              <a:rPr lang="en-US" sz="1400" dirty="0">
+                <a:solidFill>
+                  <a:schemeClr val="bg2"/>
+                </a:solidFill>
+              </a:rPr>
+              <a:t>kube-prometheus-stack</a:t>
+            </a:r>
+            <a:endParaRPr lang="en-US" sz="1400" dirty="0"/>
+          </a:p>
+          <a:p>
+            <a:pPr marL="342900" indent="-342900">
+              <a:spcAft>
+                <a:spcPts val="400"/>
+              </a:spcAft>
+              <a:buSzPct val="100000"/>
+              <a:buChar char="•"/>
+            </a:pPr>
+            <a:r>
+              <a:rPr lang="en-US" sz="1400" dirty="0">
+                <a:solidFill>
+                  <a:schemeClr val="bg2"/>
+                </a:solidFill>
+              </a:rPr>
+              <a:t>ArgoCD</a:t>
+            </a:r>
+            <a:endParaRPr lang="en-US" sz="1400" dirty="0"/>
+          </a:p>
+        </p:txBody>
+      </p:sp>
+      <p:sp>
+        <p:nvSpPr>
+          <p:cNvPr id="6" name="Text 4"/>
+          <p:cNvSpPr txBox="1"/>
+          <p:nvPr/>
+        </p:nvSpPr>
+        <p:spPr>
+          <a:xfrm>
+            <a:off x="685800" y="3703320"/>
+            <a:ext cx="3566160" cy="457200"/>
+          </a:xfrm>
+          <a:prstGeom prst="rect">
+            <a:avLst/>
+          </a:prstGeom>
+          <a:noFill/>
+          <a:ln/>
+        </p:spPr>
+        <p:txBody>
+          <a:bodyPr wrap="square" lIns="0" tIns="0" rIns="0" bIns="0" rtlCol="0" anchor="t"/>
+          <a:lstStyle/>
+          <a:p>
+            <a:pPr indent="0" marL="0">
+              <a:buNone/>
+            </a:pPr>
+            <a:r>
+              <a:rPr lang="en-US" sz="1300" b="1" dirty="0">
+                <a:solidFill>
+                  <a:schemeClr val="accent3"/>
+                </a:solidFill>
+              </a:rPr>
+              <a:t>init → plan (5 to add) → apply → destroy</a:t>
+            </a:r>
+            <a:endParaRPr lang="en-US" sz="1300" dirty="0"/>
+          </a:p>
+        </p:txBody>
+      </p:sp>
+      <p:sp>
+        <p:nvSpPr>
+          <p:cNvPr id="7" name="tf-aws"/>
+          <p:cNvSpPr/>
+          <p:nvPr/>
+        </p:nvSpPr>
+        <p:spPr>
+          <a:xfrm>
+            <a:off x="4709160" y="1143000"/>
+            <a:ext cx="3977640" cy="3291840"/>
+          </a:xfrm>
+          <a:prstGeom prst="roundRect">
+            <a:avLst>
+              <a:gd name="adj" fmla="val 2778"/>
             </a:avLst>
           </a:prstGeom>
           <a:solidFill>
             <a:schemeClr val="bg2"/>
           </a:solidFill>
-          <a:ln w="15875">
-            <a:solidFill>
-              <a:schemeClr val="accent1"/>
-            </a:solidFill>
-            <a:prstDash val="solid"/>
-          </a:ln>
-        </p:spPr>
-      </p:sp>
-      <p:sp>
-        <p:nvSpPr>
-          <p:cNvPr id="4" name="Text 2"/>
-          <p:cNvSpPr txBox="1"/>
-          <p:nvPr/>
-        </p:nvSpPr>
-        <p:spPr>
-          <a:xfrm>
-            <a:off x="640080" y="1234440"/>
-            <a:ext cx="4114800" cy="274320"/>
+          <a:ln/>
+          <a:effectLst>
+            <a:outerShdw sx="100000" sy="100000" kx="0" ky="0" algn="bl" rotWithShape="0" blurRad="76200" dist="25400" dir="5400000">
+              <a:srgbClr val="000000">
+                <a:alpha val="12000"/>
+              </a:srgbClr>
+            </a:outerShdw>
+          </a:effectLst>
+        </p:spPr>
+      </p:sp>
+      <p:sp>
+        <p:nvSpPr>
+          <p:cNvPr id="8" name="Text 6"/>
+          <p:cNvSpPr txBox="1"/>
+          <p:nvPr/>
+        </p:nvSpPr>
+        <p:spPr>
+          <a:xfrm>
+            <a:off x="4937760" y="1280160"/>
+            <a:ext cx="3566160" cy="365760"/>
           </a:xfrm>
           <a:prstGeom prst="rect">
             <a:avLst/>
@@ -7086,27 +7304,30 @@
               <a:buNone/>
             </a:pPr>
             <a:r>
-              <a:rPr lang="en-US" sz="1200" b="1" dirty="0">
+              <a:rPr lang="en-US" sz="1800" b="1" dirty="0">
                 <a:solidFill>
                   <a:schemeClr val="tx2"/>
                 </a:solidFill>
-              </a:rPr>
-              <a:t>VPC 10.0.0.0/16 · ap-south-1</a:t>
-            </a:r>
-            <a:endParaRPr lang="en-US" sz="1200" dirty="0"/>
-          </a:p>
-        </p:txBody>
-      </p:sp>
-      <p:sp>
-        <p:nvSpPr>
-          <p:cNvPr id="5" name="Text 3"/>
-          <p:cNvSpPr txBox="1"/>
-          <p:nvPr/>
-        </p:nvSpPr>
-        <p:spPr>
-          <a:xfrm>
-            <a:off x="685800" y="1600200"/>
-            <a:ext cx="2194560" cy="228600"/>
+                <a:latin typeface="Cambria" pitchFamily="34" charset="0"/>
+                <a:ea typeface="Cambria" pitchFamily="34" charset="-122"/>
+                <a:cs typeface="Cambria" pitchFamily="34" charset="-120"/>
+              </a:rPr>
+              <a:t>terraform/: AWS target</a:t>
+            </a:r>
+            <a:endParaRPr lang="en-US" sz="1800" dirty="0"/>
+          </a:p>
+        </p:txBody>
+      </p:sp>
+      <p:sp>
+        <p:nvSpPr>
+          <p:cNvPr id="9" name="Text 7"/>
+          <p:cNvSpPr txBox="1"/>
+          <p:nvPr/>
+        </p:nvSpPr>
+        <p:spPr>
+          <a:xfrm>
+            <a:off x="4937760" y="1737360"/>
+            <a:ext cx="3566160" cy="1463040"/>
           </a:xfrm>
           <a:prstGeom prst="rect">
             <a:avLst/>
@@ -7118,172 +7339,76 @@
           <a:bodyPr wrap="square" lIns="0" tIns="0" rIns="0" bIns="0" rtlCol="0" anchor="t"/>
           <a:lstStyle/>
           <a:p>
-            <a:pPr algn="ctr" indent="0" marL="0">
-              <a:buNone/>
-            </a:pPr>
-            <a:r>
-              <a:rPr lang="en-US" sz="1100" dirty="0">
+            <a:pPr marL="342900" indent="-342900">
+              <a:spcAft>
+                <a:spcPts val="400"/>
+              </a:spcAft>
+              <a:buSzPct val="100000"/>
+              <a:buChar char="•"/>
+            </a:pPr>
+            <a:r>
+              <a:rPr lang="en-US" sz="1400" dirty="0">
                 <a:solidFill>
                   <a:schemeClr val="accent4"/>
                 </a:solidFill>
               </a:rPr>
-              <a:t>AZ-a</a:t>
-            </a:r>
-            <a:endParaRPr lang="en-US" sz="1100" dirty="0"/>
-          </a:p>
-        </p:txBody>
-      </p:sp>
-      <p:sp>
-        <p:nvSpPr>
-          <p:cNvPr id="6" name="box-Public subnet"/>
-          <p:cNvSpPr/>
-          <p:nvPr/>
-        </p:nvSpPr>
-        <p:spPr>
-          <a:xfrm>
-            <a:off x="685800" y="1874520"/>
-            <a:ext cx="2194560" cy="731520"/>
-          </a:xfrm>
-          <a:prstGeom prst="roundRect">
-            <a:avLst>
-              <a:gd name="adj" fmla="val 10000"/>
-            </a:avLst>
-          </a:prstGeom>
-          <a:solidFill>
-            <a:schemeClr val="bg1"/>
-          </a:solidFill>
-          <a:ln w="12700">
-            <a:solidFill>
-              <a:schemeClr val="accent1"/>
-            </a:solidFill>
-            <a:prstDash val="solid"/>
-          </a:ln>
-        </p:spPr>
-      </p:sp>
-      <p:sp>
-        <p:nvSpPr>
-          <p:cNvPr id="7" name="Text 5"/>
-          <p:cNvSpPr txBox="1"/>
-          <p:nvPr/>
-        </p:nvSpPr>
-        <p:spPr>
-          <a:xfrm>
-            <a:off x="685800" y="1874520"/>
-            <a:ext cx="2194560" cy="731520"/>
-          </a:xfrm>
-          <a:prstGeom prst="rect">
-            <a:avLst/>
-          </a:prstGeom>
-          <a:noFill/>
-          <a:ln/>
-        </p:spPr>
-        <p:txBody>
-          <a:bodyPr wrap="square" lIns="25400" tIns="25400" rIns="25400" bIns="25400" rtlCol="0" anchor="ctr"/>
-          <a:lstStyle/>
-          <a:p>
-            <a:pPr algn="ctr" indent="0" marL="0">
-              <a:buNone/>
-            </a:pPr>
-            <a:r>
-              <a:rPr lang="en-US" sz="1200" b="1" dirty="0">
-                <a:solidFill>
-                  <a:schemeClr val="tx1"/>
-                </a:solidFill>
-              </a:rPr>
-              <a:t>Public subnet</a:t>
-            </a:r>
-            <a:endParaRPr lang="en-US" sz="1200" dirty="0"/>
-          </a:p>
-          <a:p>
-            <a:pPr algn="ctr" indent="0" marL="0">
-              <a:buNone/>
-            </a:pPr>
-            <a:r>
-              <a:rPr lang="en-US" sz="1000" dirty="0">
-                <a:solidFill>
-                  <a:schemeClr val="tx1"/>
-                </a:solidFill>
-              </a:rPr>
-              <a:t>10.0.0.0/24 · ELB · NAT</a:t>
-            </a:r>
-            <a:endParaRPr lang="en-US" sz="1200" dirty="0"/>
-          </a:p>
-        </p:txBody>
-      </p:sp>
-      <p:sp>
-        <p:nvSpPr>
-          <p:cNvPr id="8" name="box-Private subnet"/>
-          <p:cNvSpPr/>
-          <p:nvPr/>
-        </p:nvSpPr>
-        <p:spPr>
-          <a:xfrm>
-            <a:off x="685800" y="2788920"/>
-            <a:ext cx="2194560" cy="914400"/>
-          </a:xfrm>
-          <a:prstGeom prst="roundRect">
-            <a:avLst>
-              <a:gd name="adj" fmla="val 8000"/>
-            </a:avLst>
-          </a:prstGeom>
-          <a:solidFill>
-            <a:schemeClr val="bg1"/>
-          </a:solidFill>
-          <a:ln w="12700">
-            <a:solidFill>
-              <a:schemeClr val="accent1"/>
-            </a:solidFill>
-            <a:prstDash val="solid"/>
-          </a:ln>
-        </p:spPr>
-      </p:sp>
-      <p:sp>
-        <p:nvSpPr>
-          <p:cNvPr id="9" name="Text 7"/>
-          <p:cNvSpPr txBox="1"/>
-          <p:nvPr/>
-        </p:nvSpPr>
-        <p:spPr>
-          <a:xfrm>
-            <a:off x="685800" y="2788920"/>
-            <a:ext cx="2194560" cy="914400"/>
-          </a:xfrm>
-          <a:prstGeom prst="rect">
-            <a:avLst/>
-          </a:prstGeom>
-          <a:noFill/>
-          <a:ln/>
-        </p:spPr>
-        <p:txBody>
-          <a:bodyPr wrap="square" lIns="25400" tIns="25400" rIns="25400" bIns="25400" rtlCol="0" anchor="ctr"/>
-          <a:lstStyle/>
-          <a:p>
-            <a:pPr algn="ctr" indent="0" marL="0">
-              <a:buNone/>
-            </a:pPr>
-            <a:r>
-              <a:rPr lang="en-US" sz="1200" b="1" dirty="0">
-                <a:solidFill>
-                  <a:schemeClr val="tx1"/>
-                </a:solidFill>
-              </a:rPr>
-              <a:t>Private subnet</a:t>
-            </a:r>
-            <a:endParaRPr lang="en-US" sz="1200" dirty="0"/>
-          </a:p>
-          <a:p>
-            <a:pPr algn="ctr" indent="0" marL="0">
-              <a:buNone/>
-            </a:pPr>
-            <a:r>
-              <a:rPr lang="en-US" sz="1000" dirty="0">
-                <a:solidFill>
-                  <a:schemeClr val="tx1"/>
-                </a:solidFill>
-              </a:rPr>
-              <a:t>10.0.10.0/24 · EKS node t3.medium</a:t>
-            </a:r>
-            <a:endParaRPr lang="en-US" sz="1200" dirty="0"/>
+              <a:t>VPC 10.0.0.0/16 across 2 AZs</a:t>
+            </a:r>
+            <a:endParaRPr lang="en-US" sz="1400" dirty="0"/>
+          </a:p>
+          <a:p>
+            <a:pPr marL="342900" indent="-342900">
+              <a:spcAft>
+                <a:spcPts val="400"/>
+              </a:spcAft>
+              <a:buSzPct val="100000"/>
+              <a:buChar char="•"/>
+            </a:pPr>
+            <a:r>
+              <a:rPr lang="en-US" sz="1400" dirty="0">
+                <a:solidFill>
+                  <a:schemeClr val="accent4"/>
+                </a:solidFill>
+              </a:rPr>
+              <a:t>2 public + 2 private subnets, NAT</a:t>
+            </a:r>
+            <a:endParaRPr lang="en-US" sz="1400" dirty="0"/>
+          </a:p>
+          <a:p>
+            <a:pPr marL="342900" indent="-342900">
+              <a:spcAft>
+                <a:spcPts val="400"/>
+              </a:spcAft>
+              <a:buSzPct val="100000"/>
+              <a:buChar char="•"/>
+            </a:pPr>
+            <a:r>
+              <a:rPr lang="en-US" sz="1400" dirty="0">
+                <a:solidFill>
+                  <a:schemeClr val="accent4"/>
+                </a:solidFill>
+              </a:rPr>
+              <a:t>EKS + managed node group (2 × t3.medium)</a:t>
+            </a:r>
+            <a:endParaRPr lang="en-US" sz="1400" dirty="0"/>
+          </a:p>
+          <a:p>
+            <a:pPr marL="342900" indent="-342900">
+              <a:spcAft>
+                <a:spcPts val="400"/>
+              </a:spcAft>
+              <a:buSzPct val="100000"/>
+              <a:buChar char="•"/>
+            </a:pPr>
+            <a:r>
+              <a:rPr lang="en-US" sz="1400" dirty="0">
+                <a:solidFill>
+                  <a:schemeClr val="accent4"/>
+                </a:solidFill>
+              </a:rPr>
+              <a:t>EBS CSI driver via IRSA</a:t>
+            </a:r>
+            <a:endParaRPr lang="en-US" sz="1400" dirty="0"/>
           </a:p>
         </p:txBody>
       </p:sp>
@@ -7295,8 +7420,8 @@
         </p:nvSpPr>
         <p:spPr>
           <a:xfrm>
-            <a:off x="3063240" y="1600200"/>
-            <a:ext cx="2194560" cy="228600"/>
+            <a:off x="4937760" y="3520440"/>
+            <a:ext cx="3566160" cy="685800"/>
           </a:xfrm>
           <a:prstGeom prst="rect">
             <a:avLst/>
@@ -7308,196 +7433,6 @@
           <a:bodyPr wrap="square" lIns="0" tIns="0" rIns="0" bIns="0" rtlCol="0" anchor="t"/>
           <a:lstStyle/>
           <a:p>
-            <a:pPr algn="ctr" indent="0" marL="0">
-              <a:buNone/>
-            </a:pPr>
-            <a:r>
-              <a:rPr lang="en-US" sz="1100" dirty="0">
-                <a:solidFill>
-                  <a:schemeClr val="accent4"/>
-                </a:solidFill>
-              </a:rPr>
-              <a:t>AZ-b</a:t>
-            </a:r>
-            <a:endParaRPr lang="en-US" sz="1100" dirty="0"/>
-          </a:p>
-        </p:txBody>
-      </p:sp>
-      <p:sp>
-        <p:nvSpPr>
-          <p:cNvPr id="11" name="box-Public subnet"/>
-          <p:cNvSpPr/>
-          <p:nvPr/>
-        </p:nvSpPr>
-        <p:spPr>
-          <a:xfrm>
-            <a:off x="3063240" y="1874520"/>
-            <a:ext cx="2194560" cy="731520"/>
-          </a:xfrm>
-          <a:prstGeom prst="roundRect">
-            <a:avLst>
-              <a:gd name="adj" fmla="val 10000"/>
-            </a:avLst>
-          </a:prstGeom>
-          <a:solidFill>
-            <a:schemeClr val="bg1"/>
-          </a:solidFill>
-          <a:ln w="12700">
-            <a:solidFill>
-              <a:schemeClr val="accent1"/>
-            </a:solidFill>
-            <a:prstDash val="solid"/>
-          </a:ln>
-        </p:spPr>
-      </p:sp>
-      <p:sp>
-        <p:nvSpPr>
-          <p:cNvPr id="12" name="Text 10"/>
-          <p:cNvSpPr txBox="1"/>
-          <p:nvPr/>
-        </p:nvSpPr>
-        <p:spPr>
-          <a:xfrm>
-            <a:off x="3063240" y="1874520"/>
-            <a:ext cx="2194560" cy="731520"/>
-          </a:xfrm>
-          <a:prstGeom prst="rect">
-            <a:avLst/>
-          </a:prstGeom>
-          <a:noFill/>
-          <a:ln/>
-        </p:spPr>
-        <p:txBody>
-          <a:bodyPr wrap="square" lIns="25400" tIns="25400" rIns="25400" bIns="25400" rtlCol="0" anchor="ctr"/>
-          <a:lstStyle/>
-          <a:p>
-            <a:pPr algn="ctr" indent="0" marL="0">
-              <a:buNone/>
-            </a:pPr>
-            <a:r>
-              <a:rPr lang="en-US" sz="1200" b="1" dirty="0">
-                <a:solidFill>
-                  <a:schemeClr val="tx1"/>
-                </a:solidFill>
-              </a:rPr>
-              <a:t>Public subnet</a:t>
-            </a:r>
-            <a:endParaRPr lang="en-US" sz="1200" dirty="0"/>
-          </a:p>
-          <a:p>
-            <a:pPr algn="ctr" indent="0" marL="0">
-              <a:buNone/>
-            </a:pPr>
-            <a:r>
-              <a:rPr lang="en-US" sz="1000" dirty="0">
-                <a:solidFill>
-                  <a:schemeClr val="tx1"/>
-                </a:solidFill>
-              </a:rPr>
-              <a:t>10.0.1.0/24 · ELB</a:t>
-            </a:r>
-            <a:endParaRPr lang="en-US" sz="1200" dirty="0"/>
-          </a:p>
-        </p:txBody>
-      </p:sp>
-      <p:sp>
-        <p:nvSpPr>
-          <p:cNvPr id="13" name="box-Private subnet"/>
-          <p:cNvSpPr/>
-          <p:nvPr/>
-        </p:nvSpPr>
-        <p:spPr>
-          <a:xfrm>
-            <a:off x="3063240" y="2788920"/>
-            <a:ext cx="2194560" cy="914400"/>
-          </a:xfrm>
-          <a:prstGeom prst="roundRect">
-            <a:avLst>
-              <a:gd name="adj" fmla="val 8000"/>
-            </a:avLst>
-          </a:prstGeom>
-          <a:solidFill>
-            <a:schemeClr val="bg1"/>
-          </a:solidFill>
-          <a:ln w="12700">
-            <a:solidFill>
-              <a:schemeClr val="accent1"/>
-            </a:solidFill>
-            <a:prstDash val="solid"/>
-          </a:ln>
-        </p:spPr>
-      </p:sp>
-      <p:sp>
-        <p:nvSpPr>
-          <p:cNvPr id="14" name="Text 12"/>
-          <p:cNvSpPr txBox="1"/>
-          <p:nvPr/>
-        </p:nvSpPr>
-        <p:spPr>
-          <a:xfrm>
-            <a:off x="3063240" y="2788920"/>
-            <a:ext cx="2194560" cy="914400"/>
-          </a:xfrm>
-          <a:prstGeom prst="rect">
-            <a:avLst/>
-          </a:prstGeom>
-          <a:noFill/>
-          <a:ln/>
-        </p:spPr>
-        <p:txBody>
-          <a:bodyPr wrap="square" lIns="25400" tIns="25400" rIns="25400" bIns="25400" rtlCol="0" anchor="ctr"/>
-          <a:lstStyle/>
-          <a:p>
-            <a:pPr algn="ctr" indent="0" marL="0">
-              <a:buNone/>
-            </a:pPr>
-            <a:r>
-              <a:rPr lang="en-US" sz="1200" b="1" dirty="0">
-                <a:solidFill>
-                  <a:schemeClr val="tx1"/>
-                </a:solidFill>
-              </a:rPr>
-              <a:t>Private subnet</a:t>
-            </a:r>
-            <a:endParaRPr lang="en-US" sz="1200" dirty="0"/>
-          </a:p>
-          <a:p>
-            <a:pPr algn="ctr" indent="0" marL="0">
-              <a:buNone/>
-            </a:pPr>
-            <a:r>
-              <a:rPr lang="en-US" sz="1000" dirty="0">
-                <a:solidFill>
-                  <a:schemeClr val="tx1"/>
-                </a:solidFill>
-              </a:rPr>
-              <a:t>10.0.11.0/24 · EKS node t3.medium</a:t>
-            </a:r>
-            <a:endParaRPr lang="en-US" sz="1200" dirty="0"/>
-          </a:p>
-        </p:txBody>
-      </p:sp>
-      <p:sp>
-        <p:nvSpPr>
-          <p:cNvPr id="15" name="Text 13"/>
-          <p:cNvSpPr txBox="1"/>
-          <p:nvPr/>
-        </p:nvSpPr>
-        <p:spPr>
-          <a:xfrm>
-            <a:off x="685800" y="3886200"/>
-            <a:ext cx="4572000" cy="365760"/>
-          </a:xfrm>
-          <a:prstGeom prst="rect">
-            <a:avLst/>
-          </a:prstGeom>
-          <a:noFill/>
-          <a:ln/>
-        </p:spPr>
-        <p:txBody>
-          <a:bodyPr wrap="square" lIns="0" tIns="0" rIns="0" bIns="0" rtlCol="0" anchor="t"/>
-          <a:lstStyle/>
-          <a:p>
             <a:pPr indent="0" marL="0">
               <a:buNone/>
             </a:pPr>
@@ -7507,295 +7442,7 @@
                   <a:schemeClr val="accent1"/>
                 </a:solidFill>
               </a:rPr>
-              <a:t>EKS control plane (managed by AWS)</a:t>
-            </a:r>
-            <a:endParaRPr lang="en-US" sz="1200" dirty="0"/>
-          </a:p>
-        </p:txBody>
-      </p:sp>
-      <p:sp>
-        <p:nvSpPr>
-          <p:cNvPr id="16" name="Text 14"/>
-          <p:cNvSpPr txBox="1"/>
-          <p:nvPr/>
-        </p:nvSpPr>
-        <p:spPr>
-          <a:xfrm>
-            <a:off x="5715000" y="1143000"/>
-            <a:ext cx="2971800" cy="292608"/>
-          </a:xfrm>
-          <a:prstGeom prst="rect">
-            <a:avLst/>
-          </a:prstGeom>
-          <a:noFill/>
-          <a:ln/>
-        </p:spPr>
-        <p:txBody>
-          <a:bodyPr wrap="square" lIns="0" tIns="0" rIns="0" bIns="0" rtlCol="0" anchor="t"/>
-          <a:lstStyle/>
-          <a:p>
-            <a:pPr indent="0" marL="0">
-              <a:buNone/>
-            </a:pPr>
-            <a:r>
-              <a:rPr lang="en-US" sz="1500" b="1" dirty="0">
-                <a:solidFill>
-                  <a:schemeClr val="tx2"/>
-                </a:solidFill>
-              </a:rPr>
-              <a:t>Modules</a:t>
-            </a:r>
-            <a:endParaRPr lang="en-US" sz="1500" dirty="0"/>
-          </a:p>
-        </p:txBody>
-      </p:sp>
-      <p:sp>
-        <p:nvSpPr>
-          <p:cNvPr id="17" name="Text 15"/>
-          <p:cNvSpPr txBox="1"/>
-          <p:nvPr/>
-        </p:nvSpPr>
-        <p:spPr>
-          <a:xfrm>
-            <a:off x="5715000" y="1444752"/>
-            <a:ext cx="2971800" cy="457200"/>
-          </a:xfrm>
-          <a:prstGeom prst="rect">
-            <a:avLst/>
-          </a:prstGeom>
-          <a:noFill/>
-          <a:ln/>
-        </p:spPr>
-        <p:txBody>
-          <a:bodyPr wrap="square" lIns="0" tIns="0" rIns="0" bIns="0" rtlCol="0" anchor="t"/>
-          <a:lstStyle/>
-          <a:p>
-            <a:pPr indent="0" marL="0">
-              <a:buNone/>
-            </a:pPr>
-            <a:r>
-              <a:rPr lang="en-US" sz="1200" dirty="0">
-                <a:solidFill>
-                  <a:schemeClr val="accent4"/>
-                </a:solidFill>
-              </a:rPr>
-              <a:t>terraform-aws-modules: vpc, eks, iam</a:t>
-            </a:r>
-            <a:endParaRPr lang="en-US" sz="1200" dirty="0"/>
-          </a:p>
-        </p:txBody>
-      </p:sp>
-      <p:sp>
-        <p:nvSpPr>
-          <p:cNvPr id="18" name="Text 16"/>
-          <p:cNvSpPr txBox="1"/>
-          <p:nvPr/>
-        </p:nvSpPr>
-        <p:spPr>
-          <a:xfrm>
-            <a:off x="5715000" y="1984248"/>
-            <a:ext cx="2971800" cy="292608"/>
-          </a:xfrm>
-          <a:prstGeom prst="rect">
-            <a:avLst/>
-          </a:prstGeom>
-          <a:noFill/>
-          <a:ln/>
-        </p:spPr>
-        <p:txBody>
-          <a:bodyPr wrap="square" lIns="0" tIns="0" rIns="0" bIns="0" rtlCol="0" anchor="t"/>
-          <a:lstStyle/>
-          <a:p>
-            <a:pPr indent="0" marL="0">
-              <a:buNone/>
-            </a:pPr>
-            <a:r>
-              <a:rPr lang="en-US" sz="1500" b="1" dirty="0">
-                <a:solidFill>
-                  <a:schemeClr val="tx2"/>
-                </a:solidFill>
-              </a:rPr>
-              <a:t>Node group</a:t>
-            </a:r>
-            <a:endParaRPr lang="en-US" sz="1500" dirty="0"/>
-          </a:p>
-        </p:txBody>
-      </p:sp>
-      <p:sp>
-        <p:nvSpPr>
-          <p:cNvPr id="19" name="Text 17"/>
-          <p:cNvSpPr txBox="1"/>
-          <p:nvPr/>
-        </p:nvSpPr>
-        <p:spPr>
-          <a:xfrm>
-            <a:off x="5715000" y="2286000"/>
-            <a:ext cx="2971800" cy="457200"/>
-          </a:xfrm>
-          <a:prstGeom prst="rect">
-            <a:avLst/>
-          </a:prstGeom>
-          <a:noFill/>
-          <a:ln/>
-        </p:spPr>
-        <p:txBody>
-          <a:bodyPr wrap="square" lIns="0" tIns="0" rIns="0" bIns="0" rtlCol="0" anchor="t"/>
-          <a:lstStyle/>
-          <a:p>
-            <a:pPr indent="0" marL="0">
-              <a:buNone/>
-            </a:pPr>
-            <a:r>
-              <a:rPr lang="en-US" sz="1200" dirty="0">
-                <a:solidFill>
-                  <a:schemeClr val="accent4"/>
-                </a:solidFill>
-              </a:rPr>
-              <a:t>managed AL2023 group, 2 × t3.medium (1–3)</a:t>
-            </a:r>
-            <a:endParaRPr lang="en-US" sz="1200" dirty="0"/>
-          </a:p>
-        </p:txBody>
-      </p:sp>
-      <p:sp>
-        <p:nvSpPr>
-          <p:cNvPr id="20" name="Text 18"/>
-          <p:cNvSpPr txBox="1"/>
-          <p:nvPr/>
-        </p:nvSpPr>
-        <p:spPr>
-          <a:xfrm>
-            <a:off x="5715000" y="2825496"/>
-            <a:ext cx="2971800" cy="292608"/>
-          </a:xfrm>
-          <a:prstGeom prst="rect">
-            <a:avLst/>
-          </a:prstGeom>
-          <a:noFill/>
-          <a:ln/>
-        </p:spPr>
-        <p:txBody>
-          <a:bodyPr wrap="square" lIns="0" tIns="0" rIns="0" bIns="0" rtlCol="0" anchor="t"/>
-          <a:lstStyle/>
-          <a:p>
-            <a:pPr indent="0" marL="0">
-              <a:buNone/>
-            </a:pPr>
-            <a:r>
-              <a:rPr lang="en-US" sz="1500" b="1" dirty="0">
-                <a:solidFill>
-                  <a:schemeClr val="tx2"/>
-                </a:solidFill>
-              </a:rPr>
-              <a:t>Add-ons</a:t>
-            </a:r>
-            <a:endParaRPr lang="en-US" sz="1500" dirty="0"/>
-          </a:p>
-        </p:txBody>
-      </p:sp>
-      <p:sp>
-        <p:nvSpPr>
-          <p:cNvPr id="21" name="Text 19"/>
-          <p:cNvSpPr txBox="1"/>
-          <p:nvPr/>
-        </p:nvSpPr>
-        <p:spPr>
-          <a:xfrm>
-            <a:off x="5715000" y="3127248"/>
-            <a:ext cx="2971800" cy="457200"/>
-          </a:xfrm>
-          <a:prstGeom prst="rect">
-            <a:avLst/>
-          </a:prstGeom>
-          <a:noFill/>
-          <a:ln/>
-        </p:spPr>
-        <p:txBody>
-          <a:bodyPr wrap="square" lIns="0" tIns="0" rIns="0" bIns="0" rtlCol="0" anchor="t"/>
-          <a:lstStyle/>
-          <a:p>
-            <a:pPr indent="0" marL="0">
-              <a:buNone/>
-            </a:pPr>
-            <a:r>
-              <a:rPr lang="en-US" sz="1200" dirty="0">
-                <a:solidFill>
-                  <a:schemeClr val="accent4"/>
-                </a:solidFill>
-              </a:rPr>
-              <a:t>CoreDNS, VPC CNI, kube-proxy, EBS CSI (IRSA)</a:t>
-            </a:r>
-            <a:endParaRPr lang="en-US" sz="1200" dirty="0"/>
-          </a:p>
-        </p:txBody>
-      </p:sp>
-      <p:sp>
-        <p:nvSpPr>
-          <p:cNvPr id="22" name="Text 20"/>
-          <p:cNvSpPr txBox="1"/>
-          <p:nvPr/>
-        </p:nvSpPr>
-        <p:spPr>
-          <a:xfrm>
-            <a:off x="5715000" y="3666744"/>
-            <a:ext cx="2971800" cy="292608"/>
-          </a:xfrm>
-          <a:prstGeom prst="rect">
-            <a:avLst/>
-          </a:prstGeom>
-          <a:noFill/>
-          <a:ln/>
-        </p:spPr>
-        <p:txBody>
-          <a:bodyPr wrap="square" lIns="0" tIns="0" rIns="0" bIns="0" rtlCol="0" anchor="t"/>
-          <a:lstStyle/>
-          <a:p>
-            <a:pPr indent="0" marL="0">
-              <a:buNone/>
-            </a:pPr>
-            <a:r>
-              <a:rPr lang="en-US" sz="1500" b="1" dirty="0">
-                <a:solidFill>
-                  <a:schemeClr val="tx2"/>
-                </a:solidFill>
-              </a:rPr>
-              <a:t>Lifecycle</a:t>
-            </a:r>
-            <a:endParaRPr lang="en-US" sz="1500" dirty="0"/>
-          </a:p>
-        </p:txBody>
-      </p:sp>
-      <p:sp>
-        <p:nvSpPr>
-          <p:cNvPr id="23" name="Text 21"/>
-          <p:cNvSpPr txBox="1"/>
-          <p:nvPr/>
-        </p:nvSpPr>
-        <p:spPr>
-          <a:xfrm>
-            <a:off x="5715000" y="3968496"/>
-            <a:ext cx="2971800" cy="457200"/>
-          </a:xfrm>
-          <a:prstGeom prst="rect">
-            <a:avLst/>
-          </a:prstGeom>
-          <a:noFill/>
-          <a:ln/>
-        </p:spPr>
-        <p:txBody>
-          <a:bodyPr wrap="square" lIns="0" tIns="0" rIns="0" bIns="0" rtlCol="0" anchor="t"/>
-          <a:lstStyle/>
-          <a:p>
-            <a:pPr indent="0" marL="0">
-              <a:buNone/>
-            </a:pPr>
-            <a:r>
-              <a:rPr lang="en-US" sz="1200" dirty="0">
-                <a:solidFill>
-                  <a:schemeClr val="accent4"/>
-                </a:solidFill>
-              </a:rPr>
-              <a:t>init → plan → apply (~15 min) → destroy</a:t>
+              <a:t>Written and validated. Apply is blocked until the AWS account activates.</a:t>
             </a:r>
             <a:endParaRPr lang="en-US" sz="1200" dirty="0"/>
           </a:p>
@@ -8209,7 +7856,7 @@
                   <a:schemeClr val="accent4"/>
                 </a:solidFill>
               </a:rPr>
-              <a:t>NGINX routes / to the frontend and /api to the backend, behind an AWS ELB</a:t>
+              <a:t>NGINX routes / to the frontend and /api to the backend, served on localhost</a:t>
             </a:r>
             <a:endParaRPr lang="en-US" sz="1200" dirty="0"/>
           </a:p>
@@ -8310,7 +7957,7 @@
                   <a:schemeClr val="accent4"/>
                 </a:solidFill>
               </a:rPr>
-              <a:t>Postgres StatefulSet on a 5 Gi EBS volume; credentials in a Secret</a:t>
+              <a:t>Postgres StatefulSet on a persistent volume; credentials in a Secret</a:t>
             </a:r>
             <a:endParaRPr lang="en-US" sz="1200" dirty="0"/>
           </a:p>

</xml_diff>